<commit_message>
piece of code fixed in Chapter 12, slide 20
</commit_message>
<xml_diff>
--- a/Slides/PowerPoint/Chapter12.pptx
+++ b/Slides/PowerPoint/Chapter12.pptx
@@ -248,7 +248,7 @@
           <a:p>
             <a:fld id="{C91A6552-0A6C-D244-A2C8-B478F33B238A}" type="datetimeFigureOut">
               <a:rPr lang="en-US" smtClean="0"/>
-              <a:t>1/16/26</a:t>
+              <a:t>3/22/26</a:t>
             </a:fld>
             <a:endParaRPr lang="en-US"/>
           </a:p>
@@ -6741,41 +6741,6 @@
           </a:p>
         </p:txBody>
       </p:sp>
-      <p:pic>
-        <p:nvPicPr>
-          <p:cNvPr id="18" name="Picture 17" descr="A close-up of a text&#10;&#10;AI-generated content may be incorrect.">
-            <a:extLst>
-              <a:ext uri="{FF2B5EF4-FFF2-40B4-BE49-F238E27FC236}">
-                <a16:creationId xmlns:a16="http://schemas.microsoft.com/office/drawing/2014/main" id="{EF01BC81-8455-D5FF-1E50-8DBB0423B316}"/>
-              </a:ext>
-            </a:extLst>
-          </p:cNvPr>
-          <p:cNvPicPr>
-            <a:picLocks noChangeAspect="1"/>
-          </p:cNvPicPr>
-          <p:nvPr/>
-        </p:nvPicPr>
-        <p:blipFill>
-          <a:blip r:embed="rId3"/>
-          <a:stretch>
-            <a:fillRect/>
-          </a:stretch>
-        </p:blipFill>
-        <p:spPr>
-          <a:xfrm>
-            <a:off x="751372" y="2072350"/>
-            <a:ext cx="5099914" cy="2024742"/>
-          </a:xfrm>
-          <a:prstGeom prst="rect">
-            <a:avLst/>
-          </a:prstGeom>
-          <a:ln>
-            <a:solidFill>
-              <a:schemeClr val="tx1"/>
-            </a:solidFill>
-          </a:ln>
-        </p:spPr>
-      </p:pic>
       <p:cxnSp>
         <p:nvCxnSpPr>
           <p:cNvPr id="24" name="Elbow Connector 23">
@@ -6788,7 +6753,6 @@
           <p:cNvCxnSpPr>
             <a:cxnSpLocks/>
             <a:stCxn id="10" idx="3"/>
-            <a:endCxn id="18" idx="0"/>
           </p:cNvCxnSpPr>
           <p:nvPr/>
         </p:nvCxnSpPr>
@@ -7081,6 +7045,41 @@
           </a:p>
         </p:txBody>
       </p:sp>
+      <p:pic>
+        <p:nvPicPr>
+          <p:cNvPr id="3" name="Picture 2">
+            <a:extLst>
+              <a:ext uri="{FF2B5EF4-FFF2-40B4-BE49-F238E27FC236}">
+                <a16:creationId xmlns:a16="http://schemas.microsoft.com/office/drawing/2014/main" id="{3C64667C-1DA6-0E11-06E3-66352E247245}"/>
+              </a:ext>
+            </a:extLst>
+          </p:cNvPr>
+          <p:cNvPicPr>
+            <a:picLocks noChangeAspect="1"/>
+          </p:cNvPicPr>
+          <p:nvPr/>
+        </p:nvPicPr>
+        <p:blipFill>
+          <a:blip r:embed="rId3"/>
+          <a:stretch>
+            <a:fillRect/>
+          </a:stretch>
+        </p:blipFill>
+        <p:spPr>
+          <a:xfrm>
+            <a:off x="1562346" y="2110583"/>
+            <a:ext cx="4242774" cy="1678112"/>
+          </a:xfrm>
+          <a:prstGeom prst="rect">
+            <a:avLst/>
+          </a:prstGeom>
+          <a:ln>
+            <a:solidFill>
+              <a:schemeClr val="tx1"/>
+            </a:solidFill>
+          </a:ln>
+        </p:spPr>
+      </p:pic>
     </p:spTree>
     <p:extLst>
       <p:ext uri="{BB962C8B-B14F-4D97-AF65-F5344CB8AC3E}">

</xml_diff>